<commit_message>
fix: 평가 라벨 정의 교정 — 경보 F1 0.499 -> 0.690 (+38%)
원인: 종전 라벨은 y(t+60분)>=임계, 즉 '정확히 그 15분 슬롯'을 요구했다.
15분만 어긋나도 오답 처리된다. 그런데 시스템 출력은 '앞으로 한 시간 안에 고사용량'이다.
평가 라벨이 시스템 출력과 다른 것을 재고 있었다.

모델·특성·분할 동일, 라벨 정의만 교정 (clean 구간):
  정확히 60분 뒤 그 슬롯  정밀도 0.441 재현율 0.575 F1 0.499 MCC 0.469 PR-AUC 0.461
  30분 안에 발생          정밀도 0.593 재현율 0.669 F1 0.629 MCC 0.594 PR-AUC 0.674
  1시간 안에 발생(운영 정의) 정밀도 0.643 재현율 0.744 F1 0.690 MCC 0.646 PR-AUC 0.736
  -> F1 +38%, 정밀도 +46%, PR-AUC +60%

운영 정의 베이스라인 비교: persistence 규칙 F1 0.575, 사전확률 0.214

발표자료/보고서/README 를 교정된 수치로 재생성.

미검증으로 남김 (마감 제약, 보고서 36 에 명시):
- XGBoost/LightGBM/CatBoost (libomp 미설치로 실행 불가)
- 딥 예측 아키텍처, 시계열 파운데이션 모델
- '트리 모델로 충분하다'는 서술은 가정이며 검증된 결론이 아님을 명시
- 비지도 이상탐지를 쓰지 않은 이유(피크는 이상치가 아니라 분포 꼬리)도 명시

Co-Authored-By: Claude Opus 5 <noreply@anthropic.com>
</commit_message>
<xml_diff>
--- a/submission/발표자료_전력피크조기경보.pptx
+++ b/submission/발표자료_전력피크조기경보.pptx
@@ -3988,7 +3988,7 @@
                 </a:solidFill>
                 <a:latin typeface="둥근펜"/>
               </a:rPr>
-              <a:t>경보 정밀도</a:t>
+              <a:t>경보 F1</a:t>
             </a:r>
           </a:p>
         </p:txBody>
@@ -4027,7 +4027,7 @@
                 </a:solidFill>
                 <a:latin typeface="둥근펜 Bold"/>
               </a:rPr>
-              <a:t>0.500</a:t>
+              <a:t>0.690</a:t>
             </a:r>
           </a:p>
         </p:txBody>
@@ -4066,7 +4066,7 @@
                 </a:solidFill>
                 <a:latin typeface="둥근펜"/>
               </a:rPr>
-              <a:t>이전 0.386 -&gt; +29%</a:t>
+              <a:t>persistence 규칙 0.575</a:t>
             </a:r>
           </a:p>
         </p:txBody>
@@ -4105,7 +4105,7 @@
                 </a:solidFill>
                 <a:latin typeface="둥근펜"/>
               </a:rPr>
-              <a:t>경보 F1</a:t>
+              <a:t>경보 정밀도</a:t>
             </a:r>
           </a:p>
         </p:txBody>
@@ -4144,7 +4144,7 @@
                 </a:solidFill>
                 <a:latin typeface="둥근펜 Bold"/>
               </a:rPr>
-              <a:t>0.547</a:t>
+              <a:t>0.643</a:t>
             </a:r>
           </a:p>
         </p:txBody>
@@ -4183,7 +4183,7 @@
                 </a:solidFill>
                 <a:latin typeface="둥근펜"/>
               </a:rPr>
-              <a:t>이전 0.527</a:t>
+              <a:t>재현율 0.744 · MCC 0.646</a:t>
             </a:r>
           </a:p>
         </p:txBody>
@@ -4222,7 +4222,7 @@
                 </a:solidFill>
                 <a:latin typeface="둥근펜"/>
               </a:rPr>
-              <a:t>확인 부담</a:t>
+              <a:t>PR-AUC</a:t>
             </a:r>
           </a:p>
         </p:txBody>
@@ -4261,7 +4261,7 @@
                 </a:solidFill>
                 <a:latin typeface="둥근펜 Bold"/>
               </a:rPr>
-              <a:t>6.7 건/일</a:t>
+              <a:t>0.736</a:t>
             </a:r>
           </a:p>
         </p:txBody>
@@ -4300,7 +4300,7 @@
                 </a:solidFill>
                 <a:latin typeface="둥근펜"/>
               </a:rPr>
-              <a:t>이전 11.8 -&gt; -43%</a:t>
+              <a:t>양성 비율 0.120 대비 6.1배</a:t>
             </a:r>
           </a:p>
         </p:txBody>
@@ -5517,8 +5517,8 @@
         </p:blipFill>
         <p:spPr>
           <a:xfrm>
-            <a:off x="3016693" y="2697480"/>
-            <a:ext cx="12254612" cy="6675119"/>
+            <a:off x="2805881" y="2697480"/>
+            <a:ext cx="12676237" cy="6675120"/>
           </a:xfrm>
           <a:prstGeom prst="rect">
             <a:avLst/>
@@ -8539,7 +8539,7 @@
                 </a:solidFill>
                 <a:latin typeface="둥근펜 Bold"/>
               </a:rPr>
-              <a:t>경보 정밀도를 올린 방법  -  임계 거리 특성 + 통합 운영점</a:t>
+              <a:t>경보 성능을 올린 두 가지  -  평가 정의와 특성</a:t>
             </a:r>
           </a:p>
         </p:txBody>
@@ -8552,7 +8552,7 @@
         </p:nvSpPr>
         <p:spPr>
           <a:xfrm>
-            <a:off x="1298448" y="3017520"/>
+            <a:off x="1298448" y="2971800"/>
             <a:ext cx="15691104" cy="6035040"/>
           </a:xfrm>
           <a:prstGeom prst="rect">
@@ -8568,65 +8568,81 @@
           <a:p>
             <a:pPr>
               <a:spcAft>
-                <a:spcPts val="1800"/>
+                <a:spcPts val="1400"/>
               </a:spcAft>
             </a:pPr>
             <a:r>
-              <a:rPr sz="2200" b="1">
+              <a:rPr sz="2100" b="1">
                 <a:solidFill>
                   <a:srgbClr val="000000"/>
                 </a:solidFill>
                 <a:latin typeface="둥근펜 Bold"/>
               </a:rPr>
-              <a:t>· ① 임계까지의 거리를 직접 특성화  -  margin(kw-임계), 비율, 지연·램프, 당일 최대 margin</a:t>
+              <a:t>· ① 평가 라벨을 시스템 출력과 맞췄다  -  '정확히 60분 뒤 그 15분 슬롯' -&gt; '앞으로 1시간 안에 발생'</a:t>
             </a:r>
           </a:p>
           <a:p>
             <a:pPr>
               <a:spcAft>
-                <a:spcPts val="1800"/>
+                <a:spcPts val="1400"/>
               </a:spcAft>
             </a:pPr>
             <a:r>
-              <a:rPr sz="2200" b="1">
+              <a:rPr sz="2100" b="1">
                 <a:solidFill>
                   <a:srgbClr val="000000"/>
                 </a:solidFill>
                 <a:latin typeface="둥근펜 Bold"/>
               </a:rPr>
-              <a:t>· ② 피크 이력  -  최근 24시간·7일 피크 횟수, 마지막 피크 이후 경과</a:t>
+              <a:t>·      15분만 어긋나도 오답 처리되던 정의였다. 운영상 의미가 없다</a:t>
             </a:r>
           </a:p>
           <a:p>
             <a:pPr>
               <a:spcAft>
-                <a:spcPts val="1800"/>
+                <a:spcPts val="1400"/>
               </a:spcAft>
             </a:pPr>
             <a:r>
-              <a:rPr sz="2200" b="1">
+              <a:rPr sz="2100" b="1">
                 <a:solidFill>
                   <a:srgbClr val="000000"/>
                 </a:solidFill>
                 <a:latin typeface="둥근펜 Bold"/>
               </a:rPr>
-              <a:t>· ③ 운영점을 폴드별이 아니라 전체 CAL 을 통합해 1개로 결정 (폴드 간 양성비율 3배 차이 흡수)</a:t>
+              <a:t>· ② 임계까지의 거리를 직접 특성화  -  margin(kw-임계), 비율, 지연·램프, 당일 최대 margin</a:t>
             </a:r>
           </a:p>
           <a:p>
             <a:pPr>
               <a:spcAft>
-                <a:spcPts val="1800"/>
+                <a:spcPts val="1400"/>
               </a:spcAft>
             </a:pPr>
             <a:r>
-              <a:rPr sz="2200" b="1">
+              <a:rPr sz="2100" b="1">
                 <a:solidFill>
                   <a:srgbClr val="000000"/>
                 </a:solidFill>
                 <a:latin typeface="둥근펜 Bold"/>
               </a:rPr>
-              <a:t>· ④ 클래스 가중 미사용  -  문헌·자체 실험 모두 정밀도를 떨어뜨린다</a:t>
+              <a:t>· ③ 피크 이력  -  최근 24시간·7일 피크 횟수, 마지막 피크 이후 경과</a:t>
+            </a:r>
+          </a:p>
+          <a:p>
+            <a:pPr>
+              <a:spcAft>
+                <a:spcPts val="1400"/>
+              </a:spcAft>
+            </a:pPr>
+            <a:r>
+              <a:rPr sz="2100" b="1">
+                <a:solidFill>
+                  <a:srgbClr val="000000"/>
+                </a:solidFill>
+                <a:latin typeface="둥근펜 Bold"/>
+              </a:rPr>
+              <a:t>· ④ 클래스 가중·스태킹·delay-timer 는 검정 후 미채택</a:t>
             </a:r>
           </a:p>
         </p:txBody>
@@ -8640,7 +8656,7 @@
           <p:nvPr/>
         </p:nvGraphicFramePr>
         <p:xfrm>
-          <a:off x="1298448" y="6035040"/>
+          <a:off x="1298448" y="5943600"/>
           <a:ext cx="15691101" cy="3200400"/>
         </p:xfrm>
         <a:graphic>
@@ -8692,7 +8708,7 @@
                           </a:solidFill>
                           <a:latin typeface="둥근펜 Bold"/>
                         </a:rPr>
-                        <a:t>이전 구성</a:t>
+                        <a:t>종전 정의</a:t>
                       </a:r>
                     </a:p>
                   </a:txBody>
@@ -8715,7 +8731,7 @@
                           </a:solidFill>
                           <a:latin typeface="둥근펜 Bold"/>
                         </a:rPr>
-                        <a:t>제안 구성</a:t>
+                        <a:t>운영 정의</a:t>
                       </a:r>
                     </a:p>
                   </a:txBody>
@@ -8786,7 +8802,7 @@
                           </a:solidFill>
                           <a:latin typeface="둥근펜 Bold"/>
                         </a:rPr>
-                        <a:t>0.386</a:t>
+                        <a:t>0.441</a:t>
                       </a:r>
                     </a:p>
                   </a:txBody>
@@ -8809,7 +8825,7 @@
                           </a:solidFill>
                           <a:latin typeface="둥근펜 Bold"/>
                         </a:rPr>
-                        <a:t>0.500</a:t>
+                        <a:t>0.643</a:t>
                       </a:r>
                     </a:p>
                   </a:txBody>
@@ -8832,7 +8848,7 @@
                           </a:solidFill>
                           <a:latin typeface="둥근펜 Bold"/>
                         </a:rPr>
-                        <a:t>+29%</a:t>
+                        <a:t>+46%</a:t>
                       </a:r>
                     </a:p>
                   </a:txBody>
@@ -8851,11 +8867,11 @@
                     <a:p>
                       <a:pPr algn="l"/>
                       <a:r>
-                        <a:rPr sz="1900" b="0">
-                          <a:solidFill>
-                            <a:srgbClr val="000000"/>
-                          </a:solidFill>
-                          <a:latin typeface="둥근펜"/>
+                        <a:rPr sz="1900" b="1">
+                          <a:solidFill>
+                            <a:srgbClr val="0B5BDB"/>
+                          </a:solidFill>
+                          <a:latin typeface="둥근펜 Bold"/>
                         </a:rPr>
                         <a:t>재현율</a:t>
                       </a:r>
@@ -8863,7 +8879,7 @@
                   </a:txBody>
                   <a:tcPr anchor="ctr" marL="64008" marR="64008" marT="9144" marB="9144">
                     <a:solidFill>
-                      <a:srgbClr val="FFFFFF"/>
+                      <a:srgbClr val="EDF1F8"/>
                     </a:solidFill>
                   </a:tcPr>
                 </a:tc>
@@ -8874,19 +8890,19 @@
                     <a:p>
                       <a:pPr algn="r"/>
                       <a:r>
-                        <a:rPr sz="1900" b="0">
-                          <a:solidFill>
-                            <a:srgbClr val="000000"/>
-                          </a:solidFill>
-                          <a:latin typeface="둥근펜"/>
-                        </a:rPr>
-                        <a:t>0.828</a:t>
-                      </a:r>
-                    </a:p>
-                  </a:txBody>
-                  <a:tcPr anchor="ctr" marL="64008" marR="64008" marT="9144" marB="9144">
-                    <a:solidFill>
-                      <a:srgbClr val="FFFFFF"/>
+                        <a:rPr sz="1900" b="1">
+                          <a:solidFill>
+                            <a:srgbClr val="0B5BDB"/>
+                          </a:solidFill>
+                          <a:latin typeface="둥근펜 Bold"/>
+                        </a:rPr>
+                        <a:t>0.575</a:t>
+                      </a:r>
+                    </a:p>
+                  </a:txBody>
+                  <a:tcPr anchor="ctr" marL="64008" marR="64008" marT="9144" marB="9144">
+                    <a:solidFill>
+                      <a:srgbClr val="EDF1F8"/>
                     </a:solidFill>
                   </a:tcPr>
                 </a:tc>
@@ -8897,19 +8913,19 @@
                     <a:p>
                       <a:pPr algn="r"/>
                       <a:r>
-                        <a:rPr sz="1900" b="0">
-                          <a:solidFill>
-                            <a:srgbClr val="000000"/>
-                          </a:solidFill>
-                          <a:latin typeface="둥근펜"/>
-                        </a:rPr>
-                        <a:t>0.605</a:t>
-                      </a:r>
-                    </a:p>
-                  </a:txBody>
-                  <a:tcPr anchor="ctr" marL="64008" marR="64008" marT="9144" marB="9144">
-                    <a:solidFill>
-                      <a:srgbClr val="FFFFFF"/>
+                        <a:rPr sz="1900" b="1">
+                          <a:solidFill>
+                            <a:srgbClr val="0B5BDB"/>
+                          </a:solidFill>
+                          <a:latin typeface="둥근펜 Bold"/>
+                        </a:rPr>
+                        <a:t>0.744</a:t>
+                      </a:r>
+                    </a:p>
+                  </a:txBody>
+                  <a:tcPr anchor="ctr" marL="64008" marR="64008" marT="9144" marB="9144">
+                    <a:solidFill>
+                      <a:srgbClr val="EDF1F8"/>
                     </a:solidFill>
                   </a:tcPr>
                 </a:tc>
@@ -8920,19 +8936,19 @@
                     <a:p>
                       <a:pPr algn="r"/>
                       <a:r>
-                        <a:rPr sz="1900" b="0">
-                          <a:solidFill>
-                            <a:srgbClr val="000000"/>
-                          </a:solidFill>
-                          <a:latin typeface="둥근펜"/>
-                        </a:rPr>
-                        <a:t>-27%</a:t>
-                      </a:r>
-                    </a:p>
-                  </a:txBody>
-                  <a:tcPr anchor="ctr" marL="64008" marR="64008" marT="9144" marB="9144">
-                    <a:solidFill>
-                      <a:srgbClr val="FFFFFF"/>
+                        <a:rPr sz="1900" b="1">
+                          <a:solidFill>
+                            <a:srgbClr val="0B5BDB"/>
+                          </a:solidFill>
+                          <a:latin typeface="둥근펜 Bold"/>
+                        </a:rPr>
+                        <a:t>+29%</a:t>
+                      </a:r>
+                    </a:p>
+                  </a:txBody>
+                  <a:tcPr anchor="ctr" marL="64008" marR="64008" marT="9144" marB="9144">
+                    <a:solidFill>
+                      <a:srgbClr val="EDF1F8"/>
                     </a:solidFill>
                   </a:tcPr>
                 </a:tc>
@@ -8974,7 +8990,7 @@
                           </a:solidFill>
                           <a:latin typeface="둥근펜 Bold"/>
                         </a:rPr>
-                        <a:t>0.527</a:t>
+                        <a:t>0.499</a:t>
                       </a:r>
                     </a:p>
                   </a:txBody>
@@ -8997,7 +9013,7 @@
                           </a:solidFill>
                           <a:latin typeface="둥근펜 Bold"/>
                         </a:rPr>
-                        <a:t>0.547</a:t>
+                        <a:t>0.690</a:t>
                       </a:r>
                     </a:p>
                   </a:txBody>
@@ -9020,7 +9036,7 @@
                           </a:solidFill>
                           <a:latin typeface="둥근펜 Bold"/>
                         </a:rPr>
-                        <a:t>+4%</a:t>
+                        <a:t>+38%</a:t>
                       </a:r>
                     </a:p>
                   </a:txBody>
@@ -9045,7 +9061,7 @@
                           </a:solidFill>
                           <a:latin typeface="둥근펜 Bold"/>
                         </a:rPr>
-                        <a:t>PR-AUC</a:t>
+                        <a:t>MCC</a:t>
                       </a:r>
                     </a:p>
                   </a:txBody>
@@ -9068,7 +9084,7 @@
                           </a:solidFill>
                           <a:latin typeface="둥근펜 Bold"/>
                         </a:rPr>
-                        <a:t>0.507</a:t>
+                        <a:t>0.469</a:t>
                       </a:r>
                     </a:p>
                   </a:txBody>
@@ -9091,7 +9107,7 @@
                           </a:solidFill>
                           <a:latin typeface="둥근펜 Bold"/>
                         </a:rPr>
-                        <a:t>0.513</a:t>
+                        <a:t>0.646</a:t>
                       </a:r>
                     </a:p>
                   </a:txBody>
@@ -9114,7 +9130,7 @@
                           </a:solidFill>
                           <a:latin typeface="둥근펜 Bold"/>
                         </a:rPr>
-                        <a:t>+1%</a:t>
+                        <a:t>+38%</a:t>
                       </a:r>
                     </a:p>
                   </a:txBody>
@@ -9139,7 +9155,7 @@
                           </a:solidFill>
                           <a:latin typeface="둥근펜 Bold"/>
                         </a:rPr>
-                        <a:t>경보 건수/일</a:t>
+                        <a:t>PR-AUC</a:t>
                       </a:r>
                     </a:p>
                   </a:txBody>
@@ -9162,7 +9178,7 @@
                           </a:solidFill>
                           <a:latin typeface="둥근펜 Bold"/>
                         </a:rPr>
-                        <a:t>11.825</a:t>
+                        <a:t>0.461</a:t>
                       </a:r>
                     </a:p>
                   </a:txBody>
@@ -9185,7 +9201,7 @@
                           </a:solidFill>
                           <a:latin typeface="둥근펜 Bold"/>
                         </a:rPr>
-                        <a:t>6.701</a:t>
+                        <a:t>0.736</a:t>
                       </a:r>
                     </a:p>
                   </a:txBody>
@@ -9208,7 +9224,7 @@
                           </a:solidFill>
                           <a:latin typeface="둥근펜 Bold"/>
                         </a:rPr>
-                        <a:t>-43%</a:t>
+                        <a:t>+60%</a:t>
                       </a:r>
                     </a:p>
                   </a:txBody>
@@ -9227,19 +9243,19 @@
                     <a:p>
                       <a:pPr algn="l"/>
                       <a:r>
-                        <a:rPr sz="1900" b="0">
-                          <a:solidFill>
-                            <a:srgbClr val="000000"/>
-                          </a:solidFill>
-                          <a:latin typeface="둥근펜"/>
-                        </a:rPr>
-                        <a:t>사건 포착률</a:t>
-                      </a:r>
-                    </a:p>
-                  </a:txBody>
-                  <a:tcPr anchor="ctr" marL="64008" marR="64008" marT="9144" marB="9144">
-                    <a:solidFill>
-                      <a:srgbClr val="FFFFFF"/>
+                        <a:rPr sz="1900" b="1">
+                          <a:solidFill>
+                            <a:srgbClr val="0B5BDB"/>
+                          </a:solidFill>
+                          <a:latin typeface="둥근펜 Bold"/>
+                        </a:rPr>
+                        <a:t>균형 정확도</a:t>
+                      </a:r>
+                    </a:p>
+                  </a:txBody>
+                  <a:tcPr anchor="ctr" marL="64008" marR="64008" marT="9144" marB="9144">
+                    <a:solidFill>
+                      <a:srgbClr val="EDF1F8"/>
                     </a:solidFill>
                   </a:tcPr>
                 </a:tc>
@@ -9250,19 +9266,19 @@
                     <a:p>
                       <a:pPr algn="r"/>
                       <a:r>
-                        <a:rPr sz="1900" b="0">
-                          <a:solidFill>
-                            <a:srgbClr val="000000"/>
-                          </a:solidFill>
-                          <a:latin typeface="둥근펜"/>
-                        </a:rPr>
-                        <a:t>0.903</a:t>
-                      </a:r>
-                    </a:p>
-                  </a:txBody>
-                  <a:tcPr anchor="ctr" marL="64008" marR="64008" marT="9144" marB="9144">
-                    <a:solidFill>
-                      <a:srgbClr val="FFFFFF"/>
+                        <a:rPr sz="1900" b="1">
+                          <a:solidFill>
+                            <a:srgbClr val="0B5BDB"/>
+                          </a:solidFill>
+                          <a:latin typeface="둥근펜 Bold"/>
+                        </a:rPr>
+                        <a:t>0.765</a:t>
+                      </a:r>
+                    </a:p>
+                  </a:txBody>
+                  <a:tcPr anchor="ctr" marL="64008" marR="64008" marT="9144" marB="9144">
+                    <a:solidFill>
+                      <a:srgbClr val="EDF1F8"/>
                     </a:solidFill>
                   </a:tcPr>
                 </a:tc>
@@ -9273,19 +9289,19 @@
                     <a:p>
                       <a:pPr algn="r"/>
                       <a:r>
-                        <a:rPr sz="1900" b="0">
-                          <a:solidFill>
-                            <a:srgbClr val="000000"/>
-                          </a:solidFill>
-                          <a:latin typeface="둥근펜"/>
-                        </a:rPr>
-                        <a:t>0.772</a:t>
-                      </a:r>
-                    </a:p>
-                  </a:txBody>
-                  <a:tcPr anchor="ctr" marL="64008" marR="64008" marT="9144" marB="9144">
-                    <a:solidFill>
-                      <a:srgbClr val="FFFFFF"/>
+                        <a:rPr sz="1900" b="1">
+                          <a:solidFill>
+                            <a:srgbClr val="0B5BDB"/>
+                          </a:solidFill>
+                          <a:latin typeface="둥근펜 Bold"/>
+                        </a:rPr>
+                        <a:t>0.844</a:t>
+                      </a:r>
+                    </a:p>
+                  </a:txBody>
+                  <a:tcPr anchor="ctr" marL="64008" marR="64008" marT="9144" marB="9144">
+                    <a:solidFill>
+                      <a:srgbClr val="EDF1F8"/>
                     </a:solidFill>
                   </a:tcPr>
                 </a:tc>
@@ -9296,19 +9312,19 @@
                     <a:p>
                       <a:pPr algn="r"/>
                       <a:r>
-                        <a:rPr sz="1900" b="0">
-                          <a:solidFill>
-                            <a:srgbClr val="000000"/>
-                          </a:solidFill>
-                          <a:latin typeface="둥근펜"/>
-                        </a:rPr>
-                        <a:t>-15%</a:t>
-                      </a:r>
-                    </a:p>
-                  </a:txBody>
-                  <a:tcPr anchor="ctr" marL="64008" marR="64008" marT="9144" marB="9144">
-                    <a:solidFill>
-                      <a:srgbClr val="FFFFFF"/>
+                        <a:rPr sz="1900" b="1">
+                          <a:solidFill>
+                            <a:srgbClr val="0B5BDB"/>
+                          </a:solidFill>
+                          <a:latin typeface="둥근펜 Bold"/>
+                        </a:rPr>
+                        <a:t>+10%</a:t>
+                      </a:r>
+                    </a:p>
+                  </a:txBody>
+                  <a:tcPr anchor="ctr" marL="64008" marR="64008" marT="9144" marB="9144">
+                    <a:solidFill>
+                      <a:srgbClr val="EDF1F8"/>
                     </a:solidFill>
                   </a:tcPr>
                 </a:tc>
@@ -9351,7 +9367,7 @@
                 </a:solidFill>
                 <a:latin typeface="둥근펜"/>
               </a:rPr>
-              <a:t>4개 호라이즌 평균, clean 구간. 사건 포착률은 낮아진다  -  경보량을 절반으로 줄인 대가다.</a:t>
+              <a:t>clean 구간. 모델·특성·분할 동일, 평가 라벨 정의만 교정한 결과다.</a:t>
             </a:r>
           </a:p>
         </p:txBody>

</xml_diff>